<commit_message>
Home dashboard: three headline tiles alike; a change that rounds to nothing reads 'same as Aug'
Co-Authored-By: Claude Opus 5.5 <noreply@anthropic.com>
</commit_message>
<xml_diff>
--- a/media/exports/services-sample-statements.pptx
+++ b/media/exports/services-sample-statements.pptx
@@ -5617,7 +5617,7 @@
                 </a:solidFill>
                 <a:latin typeface="Roboto"/>
               </a:rPr>
-              <a:t>Data retrieved 2pm, Tue 6 Oct 2026 · Generated 8 Oct 2026, 9:35am · Sample data · Made with Python (python-pptx)</a:t>
+              <a:t>Data retrieved 2pm, Tue 6 Oct 2026 · Generated 8 Oct 2026, 9:53am · Sample data · Made with Python (python-pptx)</a:t>
             </a:r>
           </a:p>
         </p:txBody>
@@ -7553,7 +7553,7 @@
                 </a:solidFill>
                 <a:latin typeface="Roboto"/>
               </a:rPr>
-              <a:t>Data retrieved 2pm, Tue 6 Oct 2026 · Generated 8 Oct 2026, 9:35am · Sample data · Made with Python (python-pptx)</a:t>
+              <a:t>Data retrieved 2pm, Tue 6 Oct 2026 · Generated 8 Oct 2026, 9:53am · Sample data · Made with Python (python-pptx)</a:t>
             </a:r>
           </a:p>
         </p:txBody>
@@ -8279,7 +8279,7 @@
                 </a:solidFill>
                 <a:latin typeface="Roboto"/>
               </a:rPr>
-              <a:t>Data retrieved 2pm, Tue 6 Oct 2026 · Generated 8 Oct 2026, 9:35am · Sample data · Made with Python (python-pptx)</a:t>
+              <a:t>Data retrieved 2pm, Tue 6 Oct 2026 · Generated 8 Oct 2026, 9:53am · Sample data · Made with Python (python-pptx)</a:t>
             </a:r>
           </a:p>
         </p:txBody>
@@ -10105,7 +10105,7 @@
                 </a:solidFill>
                 <a:latin typeface="Roboto"/>
               </a:rPr>
-              <a:t>Data retrieved 2pm, Tue 6 Oct 2026 · Generated 8 Oct 2026, 9:35am · Sample data · Made with Python (python-pptx)</a:t>
+              <a:t>Data retrieved 2pm, Tue 6 Oct 2026 · Generated 8 Oct 2026, 9:53am · Sample data · Made with Python (python-pptx)</a:t>
             </a:r>
           </a:p>
         </p:txBody>
@@ -12793,7 +12793,7 @@
                 </a:solidFill>
                 <a:latin typeface="Roboto"/>
               </a:rPr>
-              <a:t>Data retrieved 2pm, Tue 6 Oct 2026 · Generated 8 Oct 2026, 9:35am · Sample data · Made with Python (python-pptx)</a:t>
+              <a:t>Data retrieved 2pm, Tue 6 Oct 2026 · Generated 8 Oct 2026, 9:53am · Sample data · Made with Python (python-pptx)</a:t>
             </a:r>
           </a:p>
         </p:txBody>
@@ -13245,7 +13245,7 @@
                 </a:solidFill>
                 <a:latin typeface="Roboto"/>
               </a:rPr>
-              <a:t>Data retrieved 2pm, Tue 6 Oct 2026 · Generated 8 Oct 2026, 9:35am · Sample data · Made with Python (python-pptx)</a:t>
+              <a:t>Data retrieved 2pm, Tue 6 Oct 2026 · Generated 8 Oct 2026, 9:53am · Sample data · Made with Python (python-pptx)</a:t>
             </a:r>
           </a:p>
         </p:txBody>
@@ -13753,7 +13753,7 @@
                 </a:solidFill>
                 <a:latin typeface="Roboto"/>
               </a:rPr>
-              <a:t>Data retrieved 2pm, Tue 6 Oct 2026 · Generated 8 Oct 2026, 9:35am · Sample data · Made with Python (python-pptx)</a:t>
+              <a:t>Data retrieved 2pm, Tue 6 Oct 2026 · Generated 8 Oct 2026, 9:53am · Sample data · Made with Python (python-pptx)</a:t>
             </a:r>
           </a:p>
         </p:txBody>
@@ -14261,7 +14261,7 @@
                 </a:solidFill>
                 <a:latin typeface="Roboto"/>
               </a:rPr>
-              <a:t>Data retrieved 2pm, Tue 6 Oct 2026 · Generated 8 Oct 2026, 9:35am · Sample data · Made with Python (python-pptx)</a:t>
+              <a:t>Data retrieved 2pm, Tue 6 Oct 2026 · Generated 8 Oct 2026, 9:53am · Sample data · Made with Python (python-pptx)</a:t>
             </a:r>
           </a:p>
         </p:txBody>
@@ -14713,7 +14713,7 @@
                 </a:solidFill>
                 <a:latin typeface="Roboto"/>
               </a:rPr>
-              <a:t>Data retrieved 2pm, Tue 6 Oct 2026 · Generated 8 Oct 2026, 9:35am · Sample data · Made with Python (python-pptx)</a:t>
+              <a:t>Data retrieved 2pm, Tue 6 Oct 2026 · Generated 8 Oct 2026, 9:53am · Sample data · Made with Python (python-pptx)</a:t>
             </a:r>
           </a:p>
         </p:txBody>
@@ -15182,7 +15182,7 @@
             <a:r>
               <a:rPr sz="2600" b="1">
                 <a:solidFill>
-                  <a:srgbClr val="B42318"/>
+                  <a:srgbClr val="2F7A5D"/>
                 </a:solidFill>
                 <a:latin typeface="Roboto"/>
               </a:rPr>
@@ -15225,7 +15225,7 @@
                 </a:solidFill>
                 <a:latin typeface="Roboto"/>
               </a:rPr>
-              <a:t>▼ from $173 in Aug</a:t>
+              <a:t>■ same as Aug ($173)</a:t>
             </a:r>
           </a:p>
         </p:txBody>
@@ -15469,7 +15469,7 @@
                 </a:solidFill>
                 <a:latin typeface="Roboto"/>
               </a:rPr>
-              <a:t>Data retrieved 2pm, Tue 6 Oct 2026 · Generated 8 Oct 2026, 9:35am · Sample data · Made with Python (python-pptx)</a:t>
+              <a:t>Data retrieved 2pm, Tue 6 Oct 2026 · Generated 8 Oct 2026, 9:53am · Sample data · Made with Python (python-pptx)</a:t>
             </a:r>
           </a:p>
         </p:txBody>
@@ -15898,7 +15898,7 @@
                 </a:solidFill>
                 <a:latin typeface="Roboto"/>
               </a:rPr>
-              <a:t>Data retrieved 2pm, Tue 6 Oct 2026 · Generated 8 Oct 2026, 9:35am · Sample data · Made with Python (python-pptx)</a:t>
+              <a:t>Data retrieved 2pm, Tue 6 Oct 2026 · Generated 8 Oct 2026, 9:53am · Sample data · Made with Python (python-pptx)</a:t>
             </a:r>
           </a:p>
         </p:txBody>
@@ -16252,7 +16252,7 @@
                 </a:solidFill>
                 <a:latin typeface="Roboto"/>
               </a:rPr>
-              <a:t>Data retrieved 2pm, Tue 6 Oct 2026 · Generated 8 Oct 2026, 9:35am · Sample data · Made with Python (python-pptx)</a:t>
+              <a:t>Data retrieved 2pm, Tue 6 Oct 2026 · Generated 8 Oct 2026, 9:53am · Sample data · Made with Python (python-pptx)</a:t>
             </a:r>
           </a:p>
         </p:txBody>
@@ -17148,7 +17148,7 @@
                 </a:solidFill>
                 <a:latin typeface="Roboto"/>
               </a:rPr>
-              <a:t>Data retrieved 2pm, Tue 6 Oct 2026 · Generated 8 Oct 2026, 9:35am · Sample data · Made with Python (python-pptx)</a:t>
+              <a:t>Data retrieved 2pm, Tue 6 Oct 2026 · Generated 8 Oct 2026, 9:53am · Sample data · Made with Python (python-pptx)</a:t>
             </a:r>
           </a:p>
         </p:txBody>
@@ -17795,7 +17795,7 @@
                 </a:solidFill>
                 <a:latin typeface="Roboto"/>
               </a:rPr>
-              <a:t>Data retrieved 2pm, Tue 6 Oct 2026 · Generated 8 Oct 2026, 9:35am · Sample data · Made with Python (python-pptx)</a:t>
+              <a:t>Data retrieved 2pm, Tue 6 Oct 2026 · Generated 8 Oct 2026, 9:53am · Sample data · Made with Python (python-pptx)</a:t>
             </a:r>
           </a:p>
         </p:txBody>
@@ -18442,7 +18442,7 @@
                 </a:solidFill>
                 <a:latin typeface="Roboto"/>
               </a:rPr>
-              <a:t>Data retrieved 2pm, Tue 6 Oct 2026 · Generated 8 Oct 2026, 9:35am · Sample data · Made with Python (python-pptx)</a:t>
+              <a:t>Data retrieved 2pm, Tue 6 Oct 2026 · Generated 8 Oct 2026, 9:53am · Sample data · Made with Python (python-pptx)</a:t>
             </a:r>
           </a:p>
         </p:txBody>
@@ -20378,7 +20378,7 @@
                 </a:solidFill>
                 <a:latin typeface="Roboto"/>
               </a:rPr>
-              <a:t>Data retrieved 2pm, Tue 6 Oct 2026 · Generated 8 Oct 2026, 9:35am · Sample data · Made with Python (python-pptx)</a:t>
+              <a:t>Data retrieved 2pm, Tue 6 Oct 2026 · Generated 8 Oct 2026, 9:53am · Sample data · Made with Python (python-pptx)</a:t>
             </a:r>
           </a:p>
         </p:txBody>
@@ -21654,7 +21654,7 @@
                 </a:solidFill>
                 <a:latin typeface="Roboto"/>
               </a:rPr>
-              <a:t>Data retrieved 2pm, Tue 6 Oct 2026 · Generated 8 Oct 2026, 9:35am · Sample data · Made with Python (python-pptx)</a:t>
+              <a:t>Data retrieved 2pm, Tue 6 Oct 2026 · Generated 8 Oct 2026, 9:53am · Sample data · Made with Python (python-pptx)</a:t>
             </a:r>
           </a:p>
         </p:txBody>

</xml_diff>

<commit_message>
Intro as a panel with a close button; hero proof points and aligned 'three/fourth' rows; spreadsheets and slides, not vendor names
Co-Authored-By: Claude Opus 5.5 <noreply@anthropic.com>
</commit_message>
<xml_diff>
--- a/media/exports/services-sample-statements.pptx
+++ b/media/exports/services-sample-statements.pptx
@@ -5617,7 +5617,7 @@
                 </a:solidFill>
                 <a:latin typeface="Roboto"/>
               </a:rPr>
-              <a:t>Data retrieved 2pm, Tue 6 Oct 2026 · Generated 8 Oct 2026, 9:53am · Sample data · Made with Python (python-pptx)</a:t>
+              <a:t>Data retrieved 2pm, Tue 6 Oct 2026 · Generated 8 Oct 2026, 9:30pm · Sample data · Made with Python (python-pptx)</a:t>
             </a:r>
           </a:p>
         </p:txBody>
@@ -7553,7 +7553,7 @@
                 </a:solidFill>
                 <a:latin typeface="Roboto"/>
               </a:rPr>
-              <a:t>Data retrieved 2pm, Tue 6 Oct 2026 · Generated 8 Oct 2026, 9:53am · Sample data · Made with Python (python-pptx)</a:t>
+              <a:t>Data retrieved 2pm, Tue 6 Oct 2026 · Generated 8 Oct 2026, 9:30pm · Sample data · Made with Python (python-pptx)</a:t>
             </a:r>
           </a:p>
         </p:txBody>
@@ -8279,7 +8279,7 @@
                 </a:solidFill>
                 <a:latin typeface="Roboto"/>
               </a:rPr>
-              <a:t>Data retrieved 2pm, Tue 6 Oct 2026 · Generated 8 Oct 2026, 9:53am · Sample data · Made with Python (python-pptx)</a:t>
+              <a:t>Data retrieved 2pm, Tue 6 Oct 2026 · Generated 8 Oct 2026, 9:30pm · Sample data · Made with Python (python-pptx)</a:t>
             </a:r>
           </a:p>
         </p:txBody>
@@ -10105,7 +10105,7 @@
                 </a:solidFill>
                 <a:latin typeface="Roboto"/>
               </a:rPr>
-              <a:t>Data retrieved 2pm, Tue 6 Oct 2026 · Generated 8 Oct 2026, 9:53am · Sample data · Made with Python (python-pptx)</a:t>
+              <a:t>Data retrieved 2pm, Tue 6 Oct 2026 · Generated 8 Oct 2026, 9:30pm · Sample data · Made with Python (python-pptx)</a:t>
             </a:r>
           </a:p>
         </p:txBody>
@@ -12793,7 +12793,7 @@
                 </a:solidFill>
                 <a:latin typeface="Roboto"/>
               </a:rPr>
-              <a:t>Data retrieved 2pm, Tue 6 Oct 2026 · Generated 8 Oct 2026, 9:53am · Sample data · Made with Python (python-pptx)</a:t>
+              <a:t>Data retrieved 2pm, Tue 6 Oct 2026 · Generated 8 Oct 2026, 9:30pm · Sample data · Made with Python (python-pptx)</a:t>
             </a:r>
           </a:p>
         </p:txBody>
@@ -13245,7 +13245,7 @@
                 </a:solidFill>
                 <a:latin typeface="Roboto"/>
               </a:rPr>
-              <a:t>Data retrieved 2pm, Tue 6 Oct 2026 · Generated 8 Oct 2026, 9:53am · Sample data · Made with Python (python-pptx)</a:t>
+              <a:t>Data retrieved 2pm, Tue 6 Oct 2026 · Generated 8 Oct 2026, 9:30pm · Sample data · Made with Python (python-pptx)</a:t>
             </a:r>
           </a:p>
         </p:txBody>
@@ -13665,7 +13665,7 @@
                           </a:solidFill>
                           <a:latin typeface="Roboto"/>
                         </a:rPr>
-                        <a:t>10 (every one is in the Excel download and CSV)</a:t>
+                        <a:t>10 (every one is in the spreadsheet download and CSV)</a:t>
                       </a:r>
                     </a:p>
                   </a:txBody>
@@ -13753,7 +13753,7 @@
                 </a:solidFill>
                 <a:latin typeface="Roboto"/>
               </a:rPr>
-              <a:t>Data retrieved 2pm, Tue 6 Oct 2026 · Generated 8 Oct 2026, 9:53am · Sample data · Made with Python (python-pptx)</a:t>
+              <a:t>Data retrieved 2pm, Tue 6 Oct 2026 · Generated 8 Oct 2026, 9:30pm · Sample data · Made with Python (python-pptx)</a:t>
             </a:r>
           </a:p>
         </p:txBody>
@@ -14261,7 +14261,7 @@
                 </a:solidFill>
                 <a:latin typeface="Roboto"/>
               </a:rPr>
-              <a:t>Data retrieved 2pm, Tue 6 Oct 2026 · Generated 8 Oct 2026, 9:53am · Sample data · Made with Python (python-pptx)</a:t>
+              <a:t>Data retrieved 2pm, Tue 6 Oct 2026 · Generated 8 Oct 2026, 9:30pm · Sample data · Made with Python (python-pptx)</a:t>
             </a:r>
           </a:p>
         </p:txBody>
@@ -14713,7 +14713,7 @@
                 </a:solidFill>
                 <a:latin typeface="Roboto"/>
               </a:rPr>
-              <a:t>Data retrieved 2pm, Tue 6 Oct 2026 · Generated 8 Oct 2026, 9:53am · Sample data · Made with Python (python-pptx)</a:t>
+              <a:t>Data retrieved 2pm, Tue 6 Oct 2026 · Generated 8 Oct 2026, 9:30pm · Sample data · Made with Python (python-pptx)</a:t>
             </a:r>
           </a:p>
         </p:txBody>
@@ -15469,7 +15469,7 @@
                 </a:solidFill>
                 <a:latin typeface="Roboto"/>
               </a:rPr>
-              <a:t>Data retrieved 2pm, Tue 6 Oct 2026 · Generated 8 Oct 2026, 9:53am · Sample data · Made with Python (python-pptx)</a:t>
+              <a:t>Data retrieved 2pm, Tue 6 Oct 2026 · Generated 8 Oct 2026, 9:30pm · Sample data · Made with Python (python-pptx)</a:t>
             </a:r>
           </a:p>
         </p:txBody>
@@ -15898,7 +15898,7 @@
                 </a:solidFill>
                 <a:latin typeface="Roboto"/>
               </a:rPr>
-              <a:t>Data retrieved 2pm, Tue 6 Oct 2026 · Generated 8 Oct 2026, 9:53am · Sample data · Made with Python (python-pptx)</a:t>
+              <a:t>Data retrieved 2pm, Tue 6 Oct 2026 · Generated 8 Oct 2026, 9:30pm · Sample data · Made with Python (python-pptx)</a:t>
             </a:r>
           </a:p>
         </p:txBody>
@@ -16252,7 +16252,7 @@
                 </a:solidFill>
                 <a:latin typeface="Roboto"/>
               </a:rPr>
-              <a:t>Data retrieved 2pm, Tue 6 Oct 2026 · Generated 8 Oct 2026, 9:53am · Sample data · Made with Python (python-pptx)</a:t>
+              <a:t>Data retrieved 2pm, Tue 6 Oct 2026 · Generated 8 Oct 2026, 9:30pm · Sample data · Made with Python (python-pptx)</a:t>
             </a:r>
           </a:p>
         </p:txBody>
@@ -17148,7 +17148,7 @@
                 </a:solidFill>
                 <a:latin typeface="Roboto"/>
               </a:rPr>
-              <a:t>Data retrieved 2pm, Tue 6 Oct 2026 · Generated 8 Oct 2026, 9:53am · Sample data · Made with Python (python-pptx)</a:t>
+              <a:t>Data retrieved 2pm, Tue 6 Oct 2026 · Generated 8 Oct 2026, 9:30pm · Sample data · Made with Python (python-pptx)</a:t>
             </a:r>
           </a:p>
         </p:txBody>
@@ -17795,7 +17795,7 @@
                 </a:solidFill>
                 <a:latin typeface="Roboto"/>
               </a:rPr>
-              <a:t>Data retrieved 2pm, Tue 6 Oct 2026 · Generated 8 Oct 2026, 9:53am · Sample data · Made with Python (python-pptx)</a:t>
+              <a:t>Data retrieved 2pm, Tue 6 Oct 2026 · Generated 8 Oct 2026, 9:30pm · Sample data · Made with Python (python-pptx)</a:t>
             </a:r>
           </a:p>
         </p:txBody>
@@ -18442,7 +18442,7 @@
                 </a:solidFill>
                 <a:latin typeface="Roboto"/>
               </a:rPr>
-              <a:t>Data retrieved 2pm, Tue 6 Oct 2026 · Generated 8 Oct 2026, 9:53am · Sample data · Made with Python (python-pptx)</a:t>
+              <a:t>Data retrieved 2pm, Tue 6 Oct 2026 · Generated 8 Oct 2026, 9:30pm · Sample data · Made with Python (python-pptx)</a:t>
             </a:r>
           </a:p>
         </p:txBody>
@@ -20378,7 +20378,7 @@
                 </a:solidFill>
                 <a:latin typeface="Roboto"/>
               </a:rPr>
-              <a:t>Data retrieved 2pm, Tue 6 Oct 2026 · Generated 8 Oct 2026, 9:53am · Sample data · Made with Python (python-pptx)</a:t>
+              <a:t>Data retrieved 2pm, Tue 6 Oct 2026 · Generated 8 Oct 2026, 9:30pm · Sample data · Made with Python (python-pptx)</a:t>
             </a:r>
           </a:p>
         </p:txBody>
@@ -21654,7 +21654,7 @@
                 </a:solidFill>
                 <a:latin typeface="Roboto"/>
               </a:rPr>
-              <a:t>Data retrieved 2pm, Tue 6 Oct 2026 · Generated 8 Oct 2026, 9:53am · Sample data · Made with Python (python-pptx)</a:t>
+              <a:t>Data retrieved 2pm, Tue 6 Oct 2026 · Generated 8 Oct 2026, 9:30pm · Sample data · Made with Python (python-pptx)</a:t>
             </a:r>
           </a:p>
         </p:txBody>

</xml_diff>